<commit_message>
Feat: Re-generate 100% full text English EDA reports with complete tables and appendices
</commit_message>
<xml_diff>
--- a/BIZ-Jeonbok/reports/BIZ_Abalone_Market_Entry_Deck_EN.pptx
+++ b/BIZ-Jeonbok/reports/BIZ_Abalone_Market_Entry_Deck_EN.pptx
@@ -6,6 +6,7 @@
   </p:sldMasterIdLst>
   <p:sldIdLst>
     <p:sldId id="256" r:id="rId7"/>
+    <p:sldId id="257" r:id="rId8"/>
   </p:sldIdLst>
   <p:sldSz cx="12191695" cy="6858000" type="screen4x3"/>
   <p:notesSz cx="6858000" cy="9144000"/>
@@ -3163,6 +3164,685 @@
           </a:p>
         </p:txBody>
       </p:sp>
+    </p:spTree>
+  </p:cSld>
+  <p:clrMapOvr>
+    <a:masterClrMapping/>
+  </p:clrMapOvr>
+</p:sld>
+</file>
+
+<file path=ppt/slides/slide2.xml><?xml version="1.0" encoding="utf-8"?>
+<p:sld xmlns:a="http://schemas.openxmlformats.org/drawingml/2006/main" xmlns:p="http://schemas.openxmlformats.org/presentationml/2006/main" xmlns:r="http://schemas.openxmlformats.org/officeDocument/2006/relationships">
+  <p:cSld>
+    <p:spTree>
+      <p:nvGrpSpPr>
+        <p:cNvPr id="1" name=""/>
+        <p:cNvGrpSpPr/>
+        <p:nvPr/>
+      </p:nvGrpSpPr>
+      <p:grpSpPr/>
+      <p:sp>
+        <p:nvSpPr>
+          <p:cNvPr id="2" name="TextBox 1"/>
+          <p:cNvSpPr txBox="1"/>
+          <p:nvPr/>
+        </p:nvSpPr>
+        <p:spPr>
+          <a:xfrm>
+            <a:off x="731520" y="457200"/>
+            <a:ext cx="10698480" cy="731520"/>
+          </a:xfrm>
+          <a:prstGeom prst="rect">
+            <a:avLst/>
+          </a:prstGeom>
+          <a:noFill/>
+        </p:spPr>
+        <p:txBody>
+          <a:bodyPr wrap="none">
+            <a:spAutoFit/>
+          </a:bodyPr>
+          <a:lstStyle/>
+          <a:p>
+            <a:pPr>
+              <a:defRPr b="1" sz="2400"/>
+            </a:pPr>
+            <a:r>
+              <a:t>📌 Size Specification &amp; Pricing Matrix (CIF USD/kg)</a:t>
+            </a:r>
+          </a:p>
+        </p:txBody>
+      </p:sp>
+      <p:graphicFrame>
+        <p:nvGraphicFramePr>
+          <p:cNvPr id="3" name="Table 2"/>
+          <p:cNvGraphicFramePr>
+            <a:graphicFrameLocks noGrp="1"/>
+          </p:cNvGraphicFramePr>
+          <p:nvPr/>
+        </p:nvGraphicFramePr>
+        <p:xfrm>
+          <a:off x="731520" y="1645920"/>
+          <a:ext cx="10698480" cy="4389120"/>
+        </p:xfrm>
+        <a:graphic>
+          <a:graphicData uri="http://schemas.openxmlformats.org/drawingml/2006/table">
+            <a:tbl>
+              <a:tblPr firstRow="1" bandRow="1">
+                <a:tableStyleId>{5C22544A-7EE6-4342-B048-85BDC9FD1C3A}</a:tableStyleId>
+              </a:tblPr>
+              <a:tblGrid>
+                <a:gridCol w="1783080"/>
+                <a:gridCol w="1783080"/>
+                <a:gridCol w="1783080"/>
+                <a:gridCol w="1783080"/>
+                <a:gridCol w="1783080"/>
+                <a:gridCol w="1783080"/>
+              </a:tblGrid>
+              <a:tr h="731520">
+                <a:tc>
+                  <a:txBody>
+                    <a:bodyPr/>
+                    <a:lstStyle/>
+                    <a:p>
+                      <a:pPr>
+                        <a:defRPr sz="1100" b="1">
+                          <a:solidFill>
+                            <a:srgbClr val="FFFFFF"/>
+                          </a:solidFill>
+                        </a:defRPr>
+                      </a:pPr>
+                      <a:r>
+                        <a:t>Grade / Size Spec</a:t>
+                      </a:r>
+                    </a:p>
+                  </a:txBody>
+                  <a:tcPr>
+                    <a:solidFill>
+                      <a:srgbClr val="1F497D"/>
+                    </a:solidFill>
+                  </a:tcPr>
+                </a:tc>
+                <a:tc>
+                  <a:txBody>
+                    <a:bodyPr/>
+                    <a:lstStyle/>
+                    <a:p>
+                      <a:pPr>
+                        <a:defRPr sz="1100" b="1">
+                          <a:solidFill>
+                            <a:srgbClr val="FFFFFF"/>
+                          </a:solidFill>
+                        </a:defRPr>
+                      </a:pPr>
+                      <a:r>
+                        <a:t>Piece Weight</a:t>
+                      </a:r>
+                    </a:p>
+                  </a:txBody>
+                  <a:tcPr>
+                    <a:solidFill>
+                      <a:srgbClr val="1F497D"/>
+                    </a:solidFill>
+                  </a:tcPr>
+                </a:tc>
+                <a:tc>
+                  <a:txBody>
+                    <a:bodyPr/>
+                    <a:lstStyle/>
+                    <a:p>
+                      <a:pPr>
+                        <a:defRPr sz="1100" b="1">
+                          <a:solidFill>
+                            <a:srgbClr val="FFFFFF"/>
+                          </a:solidFill>
+                        </a:defRPr>
+                      </a:pPr>
+                      <a:r>
+                        <a:t>Major Exporters</a:t>
+                      </a:r>
+                    </a:p>
+                  </a:txBody>
+                  <a:tcPr>
+                    <a:solidFill>
+                      <a:srgbClr val="1F497D"/>
+                    </a:solidFill>
+                  </a:tcPr>
+                </a:tc>
+                <a:tc>
+                  <a:txBody>
+                    <a:bodyPr/>
+                    <a:lstStyle/>
+                    <a:p>
+                      <a:pPr>
+                        <a:defRPr sz="1100" b="1">
+                          <a:solidFill>
+                            <a:srgbClr val="FFFFFF"/>
+                          </a:solidFill>
+                        </a:defRPr>
+                      </a:pPr>
+                      <a:r>
+                        <a:t>Avg CIF Price ($/kg)</a:t>
+                      </a:r>
+                    </a:p>
+                  </a:txBody>
+                  <a:tcPr>
+                    <a:solidFill>
+                      <a:srgbClr val="1F497D"/>
+                    </a:solidFill>
+                  </a:tcPr>
+                </a:tc>
+                <a:tc>
+                  <a:txBody>
+                    <a:bodyPr/>
+                    <a:lstStyle/>
+                    <a:p>
+                      <a:pPr>
+                        <a:defRPr sz="1100" b="1">
+                          <a:solidFill>
+                            <a:srgbClr val="FFFFFF"/>
+                          </a:solidFill>
+                        </a:defRPr>
+                      </a:pPr>
+                      <a:r>
+                        <a:t>Target Market &amp; Buyer Channel</a:t>
+                      </a:r>
+                    </a:p>
+                  </a:txBody>
+                  <a:tcPr>
+                    <a:solidFill>
+                      <a:srgbClr val="1F497D"/>
+                    </a:solidFill>
+                  </a:tcPr>
+                </a:tc>
+                <a:tc>
+                  <a:txBody>
+                    <a:bodyPr/>
+                    <a:lstStyle/>
+                    <a:p>
+                      <a:pPr>
+                        <a:defRPr sz="1100" b="1">
+                          <a:solidFill>
+                            <a:srgbClr val="FFFFFF"/>
+                          </a:solidFill>
+                        </a:defRPr>
+                      </a:pPr>
+                      <a:r>
+                        <a:t>Sourcing Strategy</a:t>
+                      </a:r>
+                    </a:p>
+                  </a:txBody>
+                  <a:tcPr>
+                    <a:solidFill>
+                      <a:srgbClr val="1F497D"/>
+                    </a:solidFill>
+                  </a:tcPr>
+                </a:tc>
+              </a:tr>
+              <a:tr h="731520">
+                <a:tc>
+                  <a:txBody>
+                    <a:bodyPr/>
+                    <a:lstStyle/>
+                    <a:p>
+                      <a:pPr>
+                        <a:defRPr sz="1100"/>
+                      </a:pPr>
+                      <a:r>
+                        <a:t>Under 10 pcs/kg (Large)</a:t>
+                      </a:r>
+                    </a:p>
+                  </a:txBody>
+                  <a:tcPr/>
+                </a:tc>
+                <a:tc>
+                  <a:txBody>
+                    <a:bodyPr/>
+                    <a:lstStyle/>
+                    <a:p>
+                      <a:pPr>
+                        <a:defRPr sz="1100"/>
+                      </a:pPr>
+                      <a:r>
+                        <a:t>100g+ / pc</a:t>
+                      </a:r>
+                    </a:p>
+                  </a:txBody>
+                  <a:tcPr/>
+                </a:tc>
+                <a:tc>
+                  <a:txBody>
+                    <a:bodyPr/>
+                    <a:lstStyle/>
+                    <a:p>
+                      <a:pPr>
+                        <a:defRPr sz="1100"/>
+                      </a:pPr>
+                      <a:r>
+                        <a:t>Korea, Australia</a:t>
+                      </a:r>
+                    </a:p>
+                  </a:txBody>
+                  <a:tcPr/>
+                </a:tc>
+                <a:tc>
+                  <a:txBody>
+                    <a:bodyPr/>
+                    <a:lstStyle/>
+                    <a:p>
+                      <a:pPr>
+                        <a:defRPr sz="1100"/>
+                      </a:pPr>
+                      <a:r>
+                        <a:t>$42.0 ~ $48.0</a:t>
+                      </a:r>
+                    </a:p>
+                  </a:txBody>
+                  <a:tcPr/>
+                </a:tc>
+                <a:tc>
+                  <a:txBody>
+                    <a:bodyPr/>
+                    <a:lstStyle/>
+                    <a:p>
+                      <a:pPr>
+                        <a:defRPr sz="1100"/>
+                      </a:pPr>
+                      <a:r>
+                        <a:t>Japan High-end Omakase, Ryokan</a:t>
+                      </a:r>
+                    </a:p>
+                  </a:txBody>
+                  <a:tcPr/>
+                </a:tc>
+                <a:tc>
+                  <a:txBody>
+                    <a:bodyPr/>
+                    <a:lstStyle/>
+                    <a:p>
+                      <a:pPr>
+                        <a:defRPr sz="1100"/>
+                      </a:pPr>
+                      <a:r>
+                        <a:t>Premium Air Direct Express Offer</a:t>
+                      </a:r>
+                    </a:p>
+                  </a:txBody>
+                  <a:tcPr/>
+                </a:tc>
+              </a:tr>
+              <a:tr h="731520">
+                <a:tc>
+                  <a:txBody>
+                    <a:bodyPr/>
+                    <a:lstStyle/>
+                    <a:p>
+                      <a:pPr>
+                        <a:defRPr sz="1100"/>
+                      </a:pPr>
+                      <a:r>
+                        <a:t>10 ~ 12 pcs/kg (Med-Large)</a:t>
+                      </a:r>
+                    </a:p>
+                  </a:txBody>
+                  <a:tcPr/>
+                </a:tc>
+                <a:tc>
+                  <a:txBody>
+                    <a:bodyPr/>
+                    <a:lstStyle/>
+                    <a:p>
+                      <a:pPr>
+                        <a:defRPr sz="1100"/>
+                      </a:pPr>
+                      <a:r>
+                        <a:t>80g ~ 100g</a:t>
+                      </a:r>
+                    </a:p>
+                  </a:txBody>
+                  <a:tcPr/>
+                </a:tc>
+                <a:tc>
+                  <a:txBody>
+                    <a:bodyPr/>
+                    <a:lstStyle/>
+                    <a:p>
+                      <a:pPr>
+                        <a:defRPr sz="1100"/>
+                      </a:pPr>
+                      <a:r>
+                        <a:t>Korea (Wando)</a:t>
+                      </a:r>
+                    </a:p>
+                  </a:txBody>
+                  <a:tcPr/>
+                </a:tc>
+                <a:tc>
+                  <a:txBody>
+                    <a:bodyPr/>
+                    <a:lstStyle/>
+                    <a:p>
+                      <a:pPr>
+                        <a:defRPr sz="1100"/>
+                      </a:pPr>
+                      <a:r>
+                        <a:t>$36.0 ~ $40.0</a:t>
+                      </a:r>
+                    </a:p>
+                  </a:txBody>
+                  <a:tcPr/>
+                </a:tc>
+                <a:tc>
+                  <a:txBody>
+                    <a:bodyPr/>
+                    <a:lstStyle/>
+                    <a:p>
+                      <a:pPr>
+                        <a:defRPr sz="1100"/>
+                      </a:pPr>
+                      <a:r>
+                        <a:t>Tokyo Toyosu Wholesalers, LA</a:t>
+                      </a:r>
+                    </a:p>
+                  </a:txBody>
+                  <a:tcPr/>
+                </a:tc>
+                <a:tc>
+                  <a:txBody>
+                    <a:bodyPr/>
+                    <a:lstStyle/>
+                    <a:p>
+                      <a:pPr>
+                        <a:defRPr sz="1100"/>
+                      </a:pPr>
+                      <a:r>
+                        <a:t>Primary Export Grade, 1st Tier Wholesalers</a:t>
+                      </a:r>
+                    </a:p>
+                  </a:txBody>
+                  <a:tcPr/>
+                </a:tc>
+              </a:tr>
+              <a:tr h="731520">
+                <a:tc>
+                  <a:txBody>
+                    <a:bodyPr/>
+                    <a:lstStyle/>
+                    <a:p>
+                      <a:pPr>
+                        <a:defRPr sz="1100"/>
+                      </a:pPr>
+                      <a:r>
+                        <a:t>13 ~ 15 pcs/kg (Medium)</a:t>
+                      </a:r>
+                    </a:p>
+                  </a:txBody>
+                  <a:tcPr/>
+                </a:tc>
+                <a:tc>
+                  <a:txBody>
+                    <a:bodyPr/>
+                    <a:lstStyle/>
+                    <a:p>
+                      <a:pPr>
+                        <a:defRPr sz="1100"/>
+                      </a:pPr>
+                      <a:r>
+                        <a:t>65g ~ 80g</a:t>
+                      </a:r>
+                    </a:p>
+                  </a:txBody>
+                  <a:tcPr/>
+                </a:tc>
+                <a:tc>
+                  <a:txBody>
+                    <a:bodyPr/>
+                    <a:lstStyle/>
+                    <a:p>
+                      <a:pPr>
+                        <a:defRPr sz="1100"/>
+                      </a:pPr>
+                      <a:r>
+                        <a:t>Korea, China</a:t>
+                      </a:r>
+                    </a:p>
+                  </a:txBody>
+                  <a:tcPr/>
+                </a:tc>
+                <a:tc>
+                  <a:txBody>
+                    <a:bodyPr/>
+                    <a:lstStyle/>
+                    <a:p>
+                      <a:pPr>
+                        <a:defRPr sz="1100"/>
+                      </a:pPr>
+                      <a:r>
+                        <a:t>$30.0 ~ $34.0</a:t>
+                      </a:r>
+                    </a:p>
+                  </a:txBody>
+                  <a:tcPr/>
+                </a:tc>
+                <a:tc>
+                  <a:txBody>
+                    <a:bodyPr/>
+                    <a:lstStyle/>
+                    <a:p>
+                      <a:pPr>
+                        <a:defRPr sz="1100"/>
+                      </a:pPr>
+                      <a:r>
+                        <a:t>Kansai Restaurants, Asian Marts</a:t>
+                      </a:r>
+                    </a:p>
+                  </a:txBody>
+                  <a:tcPr/>
+                </a:tc>
+                <a:tc>
+                  <a:txBody>
+                    <a:bodyPr/>
+                    <a:lstStyle/>
+                    <a:p>
+                      <a:pPr>
+                        <a:defRPr sz="1100"/>
+                      </a:pPr>
+                      <a:r>
+                        <a:t>H-Mart, 99 Ranch Supermarket Supply</a:t>
+                      </a:r>
+                    </a:p>
+                  </a:txBody>
+                  <a:tcPr/>
+                </a:tc>
+              </a:tr>
+              <a:tr h="731520">
+                <a:tc>
+                  <a:txBody>
+                    <a:bodyPr/>
+                    <a:lstStyle/>
+                    <a:p>
+                      <a:pPr>
+                        <a:defRPr sz="1100"/>
+                      </a:pPr>
+                      <a:r>
+                        <a:t>15 ~ 20 pcs/kg (Med-Small)</a:t>
+                      </a:r>
+                    </a:p>
+                  </a:txBody>
+                  <a:tcPr/>
+                </a:tc>
+                <a:tc>
+                  <a:txBody>
+                    <a:bodyPr/>
+                    <a:lstStyle/>
+                    <a:p>
+                      <a:pPr>
+                        <a:defRPr sz="1100"/>
+                      </a:pPr>
+                      <a:r>
+                        <a:t>50g ~ 65g</a:t>
+                      </a:r>
+                    </a:p>
+                  </a:txBody>
+                  <a:tcPr/>
+                </a:tc>
+                <a:tc>
+                  <a:txBody>
+                    <a:bodyPr/>
+                    <a:lstStyle/>
+                    <a:p>
+                      <a:pPr>
+                        <a:defRPr sz="1100"/>
+                      </a:pPr>
+                      <a:r>
+                        <a:t>Korea, Vietnam</a:t>
+                      </a:r>
+                    </a:p>
+                  </a:txBody>
+                  <a:tcPr/>
+                </a:tc>
+                <a:tc>
+                  <a:txBody>
+                    <a:bodyPr/>
+                    <a:lstStyle/>
+                    <a:p>
+                      <a:pPr>
+                        <a:defRPr sz="1100"/>
+                      </a:pPr>
+                      <a:r>
+                        <a:t>$24.0 ~ $28.0</a:t>
+                      </a:r>
+                    </a:p>
+                  </a:txBody>
+                  <a:tcPr/>
+                </a:tc>
+                <a:tc>
+                  <a:txBody>
+                    <a:bodyPr/>
+                    <a:lstStyle/>
+                    <a:p>
+                      <a:pPr>
+                        <a:defRPr sz="1100"/>
+                      </a:pPr>
+                      <a:r>
+                        <a:t>Frozen IQF Processors, Foodservice</a:t>
+                      </a:r>
+                    </a:p>
+                  </a:txBody>
+                  <a:tcPr/>
+                </a:tc>
+                <a:tc>
+                  <a:txBody>
+                    <a:bodyPr/>
+                    <a:lstStyle/>
+                    <a:p>
+                      <a:pPr>
+                        <a:defRPr sz="1100"/>
+                      </a:pPr>
+                      <a:r>
+                        <a:t>Sea Reefer Container FCL Bulk Supply</a:t>
+                      </a:r>
+                    </a:p>
+                  </a:txBody>
+                  <a:tcPr/>
+                </a:tc>
+              </a:tr>
+              <a:tr h="731520">
+                <a:tc>
+                  <a:txBody>
+                    <a:bodyPr/>
+                    <a:lstStyle/>
+                    <a:p>
+                      <a:pPr>
+                        <a:defRPr sz="1100"/>
+                      </a:pPr>
+                      <a:r>
+                        <a:t>20+ pcs/kg (Small/Process)</a:t>
+                      </a:r>
+                    </a:p>
+                  </a:txBody>
+                  <a:tcPr/>
+                </a:tc>
+                <a:tc>
+                  <a:txBody>
+                    <a:bodyPr/>
+                    <a:lstStyle/>
+                    <a:p>
+                      <a:pPr>
+                        <a:defRPr sz="1100"/>
+                      </a:pPr>
+                      <a:r>
+                        <a:t>Under 50g</a:t>
+                      </a:r>
+                    </a:p>
+                  </a:txBody>
+                  <a:tcPr/>
+                </a:tc>
+                <a:tc>
+                  <a:txBody>
+                    <a:bodyPr/>
+                    <a:lstStyle/>
+                    <a:p>
+                      <a:pPr>
+                        <a:defRPr sz="1100"/>
+                      </a:pPr>
+                      <a:r>
+                        <a:t>Korea, China</a:t>
+                      </a:r>
+                    </a:p>
+                  </a:txBody>
+                  <a:tcPr/>
+                </a:tc>
+                <a:tc>
+                  <a:txBody>
+                    <a:bodyPr/>
+                    <a:lstStyle/>
+                    <a:p>
+                      <a:pPr>
+                        <a:defRPr sz="1100"/>
+                      </a:pPr>
+                      <a:r>
+                        <a:t>$18.0 ~ $22.0</a:t>
+                      </a:r>
+                    </a:p>
+                  </a:txBody>
+                  <a:tcPr/>
+                </a:tc>
+                <a:tc>
+                  <a:txBody>
+                    <a:bodyPr/>
+                    <a:lstStyle/>
+                    <a:p>
+                      <a:pPr>
+                        <a:defRPr sz="1100"/>
+                      </a:pPr>
+                      <a:r>
+                        <a:t>Canned Abalone, HMR Retort</a:t>
+                      </a:r>
+                    </a:p>
+                  </a:txBody>
+                  <a:tcPr/>
+                </a:tc>
+                <a:tc>
+                  <a:txBody>
+                    <a:bodyPr/>
+                    <a:lstStyle/>
+                    <a:p>
+                      <a:pPr>
+                        <a:defRPr sz="1100"/>
+                      </a:pPr>
+                      <a:r>
+                        <a:t>FDA LACF Certified Processing Plants</a:t>
+                      </a:r>
+                    </a:p>
+                  </a:txBody>
+                  <a:tcPr/>
+                </a:tc>
+              </a:tr>
+            </a:tbl>
+          </a:graphicData>
+        </a:graphic>
+      </p:graphicFrame>
     </p:spTree>
   </p:cSld>
   <p:clrMapOvr>

</xml_diff>